<commit_message>
implement blockchain-based university voting system
</commit_message>
<xml_diff>
--- a/Documentation/Blockchain-Based-Voting-System.pptx
+++ b/Documentation/Blockchain-Based-Voting-System.pptx
@@ -28,21 +28,21 @@
       <p:regular r:id="rId14"/>
     </p:embeddedFont>
     <p:embeddedFont>
+      <p:font typeface="Garamond" panose="02020404030301010803" pitchFamily="18" charset="0"/>
+      <p:regular r:id="rId15"/>
+      <p:bold r:id="rId16"/>
+      <p:italic r:id="rId17"/>
+    </p:embeddedFont>
+    <p:embeddedFont>
+      <p:font typeface="Host Grotesk" panose="020B0604020202020204" charset="0"/>
+      <p:regular r:id="rId18"/>
+    </p:embeddedFont>
+    <p:embeddedFont>
       <p:font typeface="Bodoni Moda" panose="020B0604020202020204" charset="0"/>
-      <p:regular r:id="rId15"/>
+      <p:regular r:id="rId19"/>
     </p:embeddedFont>
     <p:embeddedFont>
       <p:font typeface="Host Grotesk Bold" panose="020B0604020202020204" charset="0"/>
-      <p:regular r:id="rId16"/>
-    </p:embeddedFont>
-    <p:embeddedFont>
-      <p:font typeface="Garamond" panose="02020404030301010803" pitchFamily="18" charset="0"/>
-      <p:regular r:id="rId17"/>
-      <p:bold r:id="rId18"/>
-      <p:italic r:id="rId19"/>
-    </p:embeddedFont>
-    <p:embeddedFont>
-      <p:font typeface="Host Grotesk" panose="020B0604020202020204" charset="0"/>
       <p:regular r:id="rId20"/>
     </p:embeddedFont>
   </p:embeddedFontLst>
@@ -1527,7 +1527,7 @@
             <a:fld id="{B61BEF0D-F0BB-DE4B-95CE-6DB70DBA9567}" type="datetimeFigureOut">
               <a:rPr lang="en-US" dirty="0"/>
               <a:pPr/>
-              <a:t>10/3/2026</a:t>
+              <a:t>10/24/2026</a:t>
             </a:fld>
             <a:endParaRPr lang="en-US" dirty="0"/>
           </a:p>
@@ -1854,7 +1854,7 @@
             <a:fld id="{B61BEF0D-F0BB-DE4B-95CE-6DB70DBA9567}" type="datetimeFigureOut">
               <a:rPr lang="en-US" dirty="0"/>
               <a:pPr/>
-              <a:t>10/3/2026</a:t>
+              <a:t>10/24/2026</a:t>
             </a:fld>
             <a:endParaRPr lang="en-US" dirty="0"/>
           </a:p>
@@ -2105,7 +2105,7 @@
             <a:fld id="{B61BEF0D-F0BB-DE4B-95CE-6DB70DBA9567}" type="datetimeFigureOut">
               <a:rPr lang="en-US" dirty="0"/>
               <a:pPr/>
-              <a:t>10/3/2026</a:t>
+              <a:t>10/24/2026</a:t>
             </a:fld>
             <a:endParaRPr lang="en-US" dirty="0"/>
           </a:p>
@@ -2447,7 +2447,7 @@
             <a:fld id="{B61BEF0D-F0BB-DE4B-95CE-6DB70DBA9567}" type="datetimeFigureOut">
               <a:rPr lang="en-US" dirty="0"/>
               <a:pPr/>
-              <a:t>10/3/2026</a:t>
+              <a:t>10/24/2026</a:t>
             </a:fld>
             <a:endParaRPr lang="en-US" dirty="0"/>
           </a:p>
@@ -2797,7 +2797,7 @@
             <a:fld id="{B61BEF0D-F0BB-DE4B-95CE-6DB70DBA9567}" type="datetimeFigureOut">
               <a:rPr lang="en-US" dirty="0"/>
               <a:pPr/>
-              <a:t>10/3/2026</a:t>
+              <a:t>10/24/2026</a:t>
             </a:fld>
             <a:endParaRPr lang="en-US" dirty="0"/>
           </a:p>
@@ -3174,7 +3174,7 @@
             <a:fld id="{B61BEF0D-F0BB-DE4B-95CE-6DB70DBA9567}" type="datetimeFigureOut">
               <a:rPr lang="en-US" dirty="0"/>
               <a:pPr/>
-              <a:t>10/3/2026</a:t>
+              <a:t>10/24/2026</a:t>
             </a:fld>
             <a:endParaRPr lang="en-US" dirty="0"/>
           </a:p>
@@ -3647,7 +3647,7 @@
             <a:fld id="{B61BEF0D-F0BB-DE4B-95CE-6DB70DBA9567}" type="datetimeFigureOut">
               <a:rPr lang="en-US" dirty="0"/>
               <a:pPr/>
-              <a:t>10/3/2026</a:t>
+              <a:t>10/24/2026</a:t>
             </a:fld>
             <a:endParaRPr lang="en-US" dirty="0"/>
           </a:p>
@@ -3855,7 +3855,7 @@
             <a:fld id="{B61BEF0D-F0BB-DE4B-95CE-6DB70DBA9567}" type="datetimeFigureOut">
               <a:rPr lang="en-US" dirty="0"/>
               <a:pPr/>
-              <a:t>10/3/2026</a:t>
+              <a:t>10/24/2026</a:t>
             </a:fld>
             <a:endParaRPr lang="en-US" dirty="0"/>
           </a:p>
@@ -4069,7 +4069,7 @@
             <a:fld id="{B61BEF0D-F0BB-DE4B-95CE-6DB70DBA9567}" type="datetimeFigureOut">
               <a:rPr lang="en-US" dirty="0"/>
               <a:pPr/>
-              <a:t>10/3/2026</a:t>
+              <a:t>10/24/2026</a:t>
             </a:fld>
             <a:endParaRPr lang="en-US" dirty="0"/>
           </a:p>
@@ -4379,7 +4379,7 @@
           <a:p>
             <a:fld id="{52647F38-B617-4D2F-AE0A-013F0C4D2C57}" type="datetimeFigureOut">
               <a:rPr lang="en-US" dirty="0"/>
-              <a:t>10/3/2026</a:t>
+              <a:t>10/24/2026</a:t>
             </a:fld>
             <a:endParaRPr lang="en-US" dirty="0"/>
           </a:p>
@@ -4629,7 +4629,7 @@
             <a:fld id="{B61BEF0D-F0BB-DE4B-95CE-6DB70DBA9567}" type="datetimeFigureOut">
               <a:rPr lang="en-US" dirty="0"/>
               <a:pPr/>
-              <a:t>10/3/2026</a:t>
+              <a:t>10/24/2026</a:t>
             </a:fld>
             <a:endParaRPr lang="en-US" dirty="0"/>
           </a:p>
@@ -4929,7 +4929,7 @@
           <a:p>
             <a:fld id="{05BFA754-D5C3-4E66-96A6-867B257F58DC}" type="datetimeFigureOut">
               <a:rPr lang="en-US" dirty="0"/>
-              <a:t>10/3/2026</a:t>
+              <a:t>10/24/2026</a:t>
             </a:fld>
             <a:endParaRPr lang="en-US" dirty="0"/>
           </a:p>
@@ -5325,7 +5325,7 @@
             <a:fld id="{B61BEF0D-F0BB-DE4B-95CE-6DB70DBA9567}" type="datetimeFigureOut">
               <a:rPr lang="en-US" dirty="0"/>
               <a:pPr/>
-              <a:t>10/3/2026</a:t>
+              <a:t>10/24/2026</a:t>
             </a:fld>
             <a:endParaRPr lang="en-US" dirty="0"/>
           </a:p>
@@ -5477,7 +5477,7 @@
             <a:fld id="{B61BEF0D-F0BB-DE4B-95CE-6DB70DBA9567}" type="datetimeFigureOut">
               <a:rPr lang="en-US" dirty="0"/>
               <a:pPr/>
-              <a:t>10/3/2026</a:t>
+              <a:t>10/24/2026</a:t>
             </a:fld>
             <a:endParaRPr lang="en-US" dirty="0"/>
           </a:p>
@@ -5606,7 +5606,7 @@
             <a:fld id="{B61BEF0D-F0BB-DE4B-95CE-6DB70DBA9567}" type="datetimeFigureOut">
               <a:rPr lang="en-US" dirty="0"/>
               <a:pPr/>
-              <a:t>10/3/2026</a:t>
+              <a:t>10/24/2026</a:t>
             </a:fld>
             <a:endParaRPr lang="en-US" dirty="0"/>
           </a:p>
@@ -5864,7 +5864,7 @@
             <a:fld id="{B61BEF0D-F0BB-DE4B-95CE-6DB70DBA9567}" type="datetimeFigureOut">
               <a:rPr lang="en-US" dirty="0"/>
               <a:pPr/>
-              <a:t>10/3/2026</a:t>
+              <a:t>10/24/2026</a:t>
             </a:fld>
             <a:endParaRPr lang="en-US" dirty="0"/>
           </a:p>
@@ -6182,7 +6182,7 @@
             <a:fld id="{B61BEF0D-F0BB-DE4B-95CE-6DB70DBA9567}" type="datetimeFigureOut">
               <a:rPr lang="en-US" dirty="0"/>
               <a:pPr/>
-              <a:t>10/3/2026</a:t>
+              <a:t>10/24/2026</a:t>
             </a:fld>
             <a:endParaRPr lang="en-US" dirty="0"/>
           </a:p>
@@ -6536,7 +6536,7 @@
             <a:fld id="{B61BEF0D-F0BB-DE4B-95CE-6DB70DBA9567}" type="datetimeFigureOut">
               <a:rPr lang="en-US" dirty="0"/>
               <a:pPr/>
-              <a:t>10/3/2026</a:t>
+              <a:t>10/24/2026</a:t>
             </a:fld>
             <a:endParaRPr lang="en-US" dirty="0"/>
           </a:p>
@@ -7241,8 +7241,8 @@
         </p:nvSpPr>
         <p:spPr>
           <a:xfrm>
-            <a:off x="965176" y="4498578"/>
-            <a:ext cx="4328111" cy="542131"/>
+            <a:off x="965176" y="4339829"/>
+            <a:ext cx="4328111" cy="859629"/>
           </a:xfrm>
           <a:prstGeom prst="rect">
             <a:avLst/>
@@ -7326,7 +7326,63 @@
                 <a:ea typeface="Host Grotesk" pitchFamily="34" charset="-122"/>
                 <a:cs typeface="Host Grotesk" pitchFamily="34" charset="-120"/>
               </a:rPr>
-              <a:t> (54482)</a:t>
+              <a:t> (54482</a:t>
+            </a:r>
+            <a:r>
+              <a:rPr lang="en-US" sz="1400" dirty="0" smtClean="0">
+                <a:solidFill>
+                  <a:srgbClr val="1E1E1C"/>
+                </a:solidFill>
+                <a:latin typeface="Host Grotesk" pitchFamily="34" charset="0"/>
+                <a:ea typeface="Host Grotesk" pitchFamily="34" charset="-122"/>
+                <a:cs typeface="Host Grotesk" pitchFamily="34" charset="-120"/>
+              </a:rPr>
+              <a:t>)</a:t>
+            </a:r>
+          </a:p>
+          <a:p>
+            <a:pPr marL="284480" indent="-284480" algn="l">
+              <a:lnSpc>
+                <a:spcPct val="117000"/>
+              </a:lnSpc>
+              <a:buSzPct val="100000"/>
+              <a:buChar char="•"/>
+            </a:pPr>
+            <a:r>
+              <a:rPr lang="en-US" sz="1400" dirty="0" err="1" smtClean="0">
+                <a:solidFill>
+                  <a:srgbClr val="1E1E1C"/>
+                </a:solidFill>
+                <a:latin typeface="Host Grotesk" pitchFamily="34" charset="0"/>
+              </a:rPr>
+              <a:t>Nouman</a:t>
+            </a:r>
+            <a:r>
+              <a:rPr lang="en-US" sz="1400" dirty="0" smtClean="0">
+                <a:solidFill>
+                  <a:srgbClr val="1E1E1C"/>
+                </a:solidFill>
+                <a:latin typeface="Host Grotesk" pitchFamily="34" charset="0"/>
+              </a:rPr>
+              <a:t> </a:t>
+            </a:r>
+            <a:r>
+              <a:rPr lang="en-US" sz="1400" dirty="0" err="1" smtClean="0">
+                <a:solidFill>
+                  <a:srgbClr val="1E1E1C"/>
+                </a:solidFill>
+                <a:latin typeface="Host Grotesk" pitchFamily="34" charset="0"/>
+              </a:rPr>
+              <a:t>Mohsin</a:t>
+            </a:r>
+            <a:r>
+              <a:rPr lang="en-US" sz="1400" smtClean="0">
+                <a:solidFill>
+                  <a:srgbClr val="1E1E1C"/>
+                </a:solidFill>
+                <a:latin typeface="Host Grotesk" pitchFamily="34" charset="0"/>
+              </a:rPr>
+              <a:t> (52963)</a:t>
             </a:r>
             <a:endParaRPr lang="en-US" sz="1400" dirty="0"/>
           </a:p>
@@ -7763,13 +7819,13 @@
   <p:clrMapOvr>
     <a:masterClrMapping/>
   </p:clrMapOvr>
-  <mc:AlternateContent xmlns:mc="http://schemas.openxmlformats.org/markup-compatibility/2006">
-    <mc:Choice xmlns:p14="http://schemas.microsoft.com/office/powerpoint/2010/main" Requires="p14">
+  <mc:AlternateContent xmlns:mc="http://schemas.openxmlformats.org/markup-compatibility/2006" xmlns:p14="http://schemas.microsoft.com/office/powerpoint/2010/main">
+    <mc:Choice Requires="p14">
       <p:transition spd="slow" p14:dur="4000">
         <p14:vortex dir="r"/>
       </p:transition>
     </mc:Choice>
-    <mc:Fallback>
+    <mc:Fallback xmlns="">
       <p:transition spd="slow">
         <p:fade/>
       </p:transition>
@@ -8509,13 +8565,13 @@
   <p:clrMapOvr>
     <a:masterClrMapping/>
   </p:clrMapOvr>
-  <mc:AlternateContent xmlns:mc="http://schemas.openxmlformats.org/markup-compatibility/2006">
-    <mc:Choice xmlns:p14="http://schemas.microsoft.com/office/powerpoint/2010/main" Requires="p14">
+  <mc:AlternateContent xmlns:mc="http://schemas.openxmlformats.org/markup-compatibility/2006" xmlns:p14="http://schemas.microsoft.com/office/powerpoint/2010/main">
+    <mc:Choice Requires="p14">
       <p:transition spd="slow" p14:dur="1600">
         <p:blinds dir="vert"/>
       </p:transition>
     </mc:Choice>
-    <mc:Fallback>
+    <mc:Fallback xmlns="">
       <p:transition spd="slow">
         <p:blinds dir="vert"/>
       </p:transition>
@@ -8652,13 +8708,13 @@
   <p:clrMapOvr>
     <a:masterClrMapping/>
   </p:clrMapOvr>
-  <mc:AlternateContent xmlns:mc="http://schemas.openxmlformats.org/markup-compatibility/2006">
-    <mc:Choice xmlns:p15="http://schemas.microsoft.com/office/powerpoint/2012/main" Requires="p15">
+  <mc:AlternateContent xmlns:mc="http://schemas.openxmlformats.org/markup-compatibility/2006" xmlns:p15="http://schemas.microsoft.com/office/powerpoint/2012/main">
+    <mc:Choice Requires="p15">
       <p:transition xmlns:p14="http://schemas.microsoft.com/office/powerpoint/2010/main" spd="slow" p14:dur="6000">
         <p15:prstTrans prst="curtains"/>
       </p:transition>
     </mc:Choice>
-    <mc:Fallback>
+    <mc:Fallback xmlns="">
       <p:transition spd="slow">
         <p:fade/>
       </p:transition>
@@ -9569,13 +9625,13 @@
   <p:clrMapOvr>
     <a:masterClrMapping/>
   </p:clrMapOvr>
-  <mc:AlternateContent xmlns:mc="http://schemas.openxmlformats.org/markup-compatibility/2006">
-    <mc:Choice xmlns:p15="http://schemas.microsoft.com/office/powerpoint/2012/main" Requires="p15">
+  <mc:AlternateContent xmlns:mc="http://schemas.openxmlformats.org/markup-compatibility/2006" xmlns:p15="http://schemas.microsoft.com/office/powerpoint/2012/main">
+    <mc:Choice Requires="p15">
       <p:transition xmlns:p14="http://schemas.microsoft.com/office/powerpoint/2010/main" spd="slow" p14:dur="2000">
         <p15:prstTrans prst="drape"/>
       </p:transition>
     </mc:Choice>
-    <mc:Fallback>
+    <mc:Fallback xmlns="">
       <p:transition spd="slow">
         <p:fade/>
       </p:transition>
@@ -10121,13 +10177,13 @@
   <p:clrMapOvr>
     <a:masterClrMapping/>
   </p:clrMapOvr>
-  <mc:AlternateContent xmlns:mc="http://schemas.openxmlformats.org/markup-compatibility/2006">
-    <mc:Choice xmlns:p14="http://schemas.microsoft.com/office/powerpoint/2010/main" Requires="p14">
+  <mc:AlternateContent xmlns:mc="http://schemas.openxmlformats.org/markup-compatibility/2006" xmlns:p14="http://schemas.microsoft.com/office/powerpoint/2010/main">
+    <mc:Choice Requires="p14">
       <p:transition spd="slow" p14:dur="3000">
         <p14:shred/>
       </p:transition>
     </mc:Choice>
-    <mc:Fallback>
+    <mc:Fallback xmlns="">
       <p:transition spd="slow">
         <p:fade/>
       </p:transition>
@@ -11252,13 +11308,13 @@
   <p:clrMapOvr>
     <a:masterClrMapping/>
   </p:clrMapOvr>
-  <mc:AlternateContent xmlns:mc="http://schemas.openxmlformats.org/markup-compatibility/2006">
-    <mc:Choice xmlns:p15="http://schemas.microsoft.com/office/powerpoint/2012/main" Requires="p15">
+  <mc:AlternateContent xmlns:mc="http://schemas.openxmlformats.org/markup-compatibility/2006" xmlns:p15="http://schemas.microsoft.com/office/powerpoint/2012/main">
+    <mc:Choice Requires="p15">
       <p:transition xmlns:p14="http://schemas.microsoft.com/office/powerpoint/2010/main" spd="slow" p14:dur="2000">
         <p15:prstTrans prst="fallOver"/>
       </p:transition>
     </mc:Choice>
-    <mc:Fallback>
+    <mc:Fallback xmlns="">
       <p:transition spd="slow">
         <p:fade/>
       </p:transition>
@@ -11968,13 +12024,13 @@
   <p:clrMapOvr>
     <a:masterClrMapping/>
   </p:clrMapOvr>
-  <mc:AlternateContent xmlns:mc="http://schemas.openxmlformats.org/markup-compatibility/2006">
-    <mc:Choice xmlns:p15="http://schemas.microsoft.com/office/powerpoint/2012/main" Requires="p15">
+  <mc:AlternateContent xmlns:mc="http://schemas.openxmlformats.org/markup-compatibility/2006" xmlns:p15="http://schemas.microsoft.com/office/powerpoint/2012/main">
+    <mc:Choice Requires="p15">
       <p:transition xmlns:p14="http://schemas.microsoft.com/office/powerpoint/2010/main" spd="slow" p14:dur="1250">
         <p15:prstTrans prst="peelOff"/>
       </p:transition>
     </mc:Choice>
-    <mc:Fallback>
+    <mc:Fallback xmlns="">
       <p:transition spd="slow">
         <p:fade/>
       </p:transition>
@@ -12947,13 +13003,13 @@
   <p:clrMapOvr>
     <a:masterClrMapping/>
   </p:clrMapOvr>
-  <mc:AlternateContent xmlns:mc="http://schemas.openxmlformats.org/markup-compatibility/2006">
-    <mc:Choice xmlns:p15="http://schemas.microsoft.com/office/powerpoint/2012/main" Requires="p15">
+  <mc:AlternateContent xmlns:mc="http://schemas.openxmlformats.org/markup-compatibility/2006" xmlns:p15="http://schemas.microsoft.com/office/powerpoint/2012/main">
+    <mc:Choice Requires="p15">
       <p:transition xmlns:p14="http://schemas.microsoft.com/office/powerpoint/2010/main" spd="slow" p14:dur="1250">
         <p15:prstTrans prst="pageCurlDouble"/>
       </p:transition>
     </mc:Choice>
-    <mc:Fallback>
+    <mc:Fallback xmlns="">
       <p:transition spd="slow">
         <p:fade/>
       </p:transition>
@@ -13096,14 +13152,14 @@
                 <a:gridCol w="1364422">
                   <a:extLst>
                     <a:ext uri="{9D8B030D-6E8A-4147-A177-3AD203B41FA5}">
-                      <a16:colId xmlns:a16="http://schemas.microsoft.com/office/drawing/2014/main" xmlns="" val="20000"/>
+                      <a16:colId xmlns="" xmlns:a16="http://schemas.microsoft.com/office/drawing/2014/main" val="20000"/>
                     </a:ext>
                   </a:extLst>
                 </a:gridCol>
                 <a:gridCol w="2648678">
                   <a:extLst>
                     <a:ext uri="{9D8B030D-6E8A-4147-A177-3AD203B41FA5}">
-                      <a16:colId xmlns:a16="http://schemas.microsoft.com/office/drawing/2014/main" xmlns="" val="20001"/>
+                      <a16:colId xmlns="" xmlns:a16="http://schemas.microsoft.com/office/drawing/2014/main" val="20001"/>
                     </a:ext>
                   </a:extLst>
                 </a:gridCol>
@@ -13241,7 +13297,7 @@
                 </a:tc>
                 <a:extLst>
                   <a:ext uri="{0D108BD9-81ED-4DB2-BD59-A6C34878D82A}">
-                    <a16:rowId xmlns:a16="http://schemas.microsoft.com/office/drawing/2014/main" xmlns="" val="10000"/>
+                    <a16:rowId xmlns="" xmlns:a16="http://schemas.microsoft.com/office/drawing/2014/main" val="10000"/>
                   </a:ext>
                 </a:extLst>
               </a:tr>
@@ -13378,7 +13434,7 @@
                 </a:tc>
                 <a:extLst>
                   <a:ext uri="{0D108BD9-81ED-4DB2-BD59-A6C34878D82A}">
-                    <a16:rowId xmlns:a16="http://schemas.microsoft.com/office/drawing/2014/main" xmlns="" val="10001"/>
+                    <a16:rowId xmlns="" xmlns:a16="http://schemas.microsoft.com/office/drawing/2014/main" val="10001"/>
                   </a:ext>
                 </a:extLst>
               </a:tr>
@@ -13515,7 +13571,7 @@
                 </a:tc>
                 <a:extLst>
                   <a:ext uri="{0D108BD9-81ED-4DB2-BD59-A6C34878D82A}">
-                    <a16:rowId xmlns:a16="http://schemas.microsoft.com/office/drawing/2014/main" xmlns="" val="10002"/>
+                    <a16:rowId xmlns="" xmlns:a16="http://schemas.microsoft.com/office/drawing/2014/main" val="10002"/>
                   </a:ext>
                 </a:extLst>
               </a:tr>
@@ -13652,7 +13708,7 @@
                 </a:tc>
                 <a:extLst>
                   <a:ext uri="{0D108BD9-81ED-4DB2-BD59-A6C34878D82A}">
-                    <a16:rowId xmlns:a16="http://schemas.microsoft.com/office/drawing/2014/main" xmlns="" val="10003"/>
+                    <a16:rowId xmlns="" xmlns:a16="http://schemas.microsoft.com/office/drawing/2014/main" val="10003"/>
                   </a:ext>
                 </a:extLst>
               </a:tr>
@@ -13789,7 +13845,7 @@
                 </a:tc>
                 <a:extLst>
                   <a:ext uri="{0D108BD9-81ED-4DB2-BD59-A6C34878D82A}">
-                    <a16:rowId xmlns:a16="http://schemas.microsoft.com/office/drawing/2014/main" xmlns="" val="10004"/>
+                    <a16:rowId xmlns="" xmlns:a16="http://schemas.microsoft.com/office/drawing/2014/main" val="10004"/>
                   </a:ext>
                 </a:extLst>
               </a:tr>
@@ -13926,7 +13982,7 @@
                 </a:tc>
                 <a:extLst>
                   <a:ext uri="{0D108BD9-81ED-4DB2-BD59-A6C34878D82A}">
-                    <a16:rowId xmlns:a16="http://schemas.microsoft.com/office/drawing/2014/main" xmlns="" val="10005"/>
+                    <a16:rowId xmlns="" xmlns:a16="http://schemas.microsoft.com/office/drawing/2014/main" val="10005"/>
                   </a:ext>
                 </a:extLst>
               </a:tr>
@@ -14063,7 +14119,7 @@
                 </a:tc>
                 <a:extLst>
                   <a:ext uri="{0D108BD9-81ED-4DB2-BD59-A6C34878D82A}">
-                    <a16:rowId xmlns:a16="http://schemas.microsoft.com/office/drawing/2014/main" xmlns="" val="10006"/>
+                    <a16:rowId xmlns="" xmlns:a16="http://schemas.microsoft.com/office/drawing/2014/main" val="10006"/>
                   </a:ext>
                 </a:extLst>
               </a:tr>
@@ -14200,7 +14256,7 @@
                 </a:tc>
                 <a:extLst>
                   <a:ext uri="{0D108BD9-81ED-4DB2-BD59-A6C34878D82A}">
-                    <a16:rowId xmlns:a16="http://schemas.microsoft.com/office/drawing/2014/main" xmlns="" val="10007"/>
+                    <a16:rowId xmlns="" xmlns:a16="http://schemas.microsoft.com/office/drawing/2014/main" val="10007"/>
                   </a:ext>
                 </a:extLst>
               </a:tr>
@@ -14881,13 +14937,13 @@
   <p:clrMapOvr>
     <a:masterClrMapping/>
   </p:clrMapOvr>
-  <mc:AlternateContent xmlns:mc="http://schemas.openxmlformats.org/markup-compatibility/2006">
-    <mc:Choice xmlns:p15="http://schemas.microsoft.com/office/powerpoint/2012/main" Requires="p15">
+  <mc:AlternateContent xmlns:mc="http://schemas.openxmlformats.org/markup-compatibility/2006" xmlns:p15="http://schemas.microsoft.com/office/powerpoint/2012/main">
+    <mc:Choice Requires="p15">
       <p:transition xmlns:p14="http://schemas.microsoft.com/office/powerpoint/2010/main" spd="slow" p14:dur="2000">
         <p15:prstTrans prst="crush"/>
       </p:transition>
     </mc:Choice>
-    <mc:Fallback>
+    <mc:Fallback xmlns="">
       <p:transition spd="slow">
         <p:fade/>
       </p:transition>
@@ -15299,13 +15355,13 @@
   <p:clrMapOvr>
     <a:masterClrMapping/>
   </p:clrMapOvr>
-  <mc:AlternateContent xmlns:mc="http://schemas.openxmlformats.org/markup-compatibility/2006">
-    <mc:Choice xmlns:p15="http://schemas.microsoft.com/office/powerpoint/2012/main" Requires="p15">
+  <mc:AlternateContent xmlns:mc="http://schemas.openxmlformats.org/markup-compatibility/2006" xmlns:p15="http://schemas.microsoft.com/office/powerpoint/2012/main">
+    <mc:Choice Requires="p15">
       <p:transition xmlns:p14="http://schemas.microsoft.com/office/powerpoint/2010/main" spd="slow" p14:dur="1250">
         <p15:prstTrans prst="airplane"/>
       </p:transition>
     </mc:Choice>
-    <mc:Fallback>
+    <mc:Fallback xmlns="">
       <p:transition spd="slow">
         <p:fade/>
       </p:transition>
@@ -16078,13 +16134,13 @@
   <p:clrMapOvr>
     <a:masterClrMapping/>
   </p:clrMapOvr>
-  <mc:AlternateContent xmlns:mc="http://schemas.openxmlformats.org/markup-compatibility/2006">
-    <mc:Choice xmlns:p15="http://schemas.microsoft.com/office/powerpoint/2012/main" Requires="p15">
+  <mc:AlternateContent xmlns:mc="http://schemas.openxmlformats.org/markup-compatibility/2006" xmlns:p15="http://schemas.microsoft.com/office/powerpoint/2012/main">
+    <mc:Choice Requires="p15">
       <p:transition xmlns:p14="http://schemas.microsoft.com/office/powerpoint/2010/main" spd="slow" p14:dur="2000">
         <p15:prstTrans prst="fracture"/>
       </p:transition>
     </mc:Choice>
-    <mc:Fallback>
+    <mc:Fallback xmlns="">
       <p:transition spd="slow">
         <p:fade/>
       </p:transition>

</xml_diff>